<commit_message>
Keep competitor capture block at standard top position for consistency
Co-Authored-By: Claude Opus 5.5 <noreply@anthropic.com>
Claude-Session: https://claude.ai/code/session_01LNckV4PF1WFWnv5VJ442kU
</commit_message>
<xml_diff>
--- a/쿠팡_경쟁사브랜드검색_1장.pptx
+++ b/쿠팡_경쟁사브랜드검색_1장.pptx
@@ -4113,7 +4113,7 @@
         </p:nvSpPr>
         <p:spPr>
           <a:xfrm>
-            <a:off x="548640" y="2548119"/>
+            <a:off x="548640" y="1993392"/>
             <a:ext cx="3505200" cy="292608"/>
           </a:xfrm>
           <a:prstGeom prst="rect">
@@ -4161,7 +4161,7 @@
         </p:nvSpPr>
         <p:spPr>
           <a:xfrm>
-            <a:off x="4328160" y="2548119"/>
+            <a:off x="4328160" y="1993392"/>
             <a:ext cx="3505200" cy="292608"/>
           </a:xfrm>
           <a:prstGeom prst="rect">
@@ -4217,7 +4217,7 @@
         </p:blipFill>
         <p:spPr>
           <a:xfrm>
-            <a:off x="548640" y="2886447"/>
+            <a:off x="548640" y="2331720"/>
             <a:ext cx="3505200" cy="1953786"/>
           </a:xfrm>
           <a:prstGeom prst="rect">
@@ -4246,7 +4246,7 @@
         </p:blipFill>
         <p:spPr>
           <a:xfrm>
-            <a:off x="4328160" y="2886447"/>
+            <a:off x="4328160" y="2331720"/>
             <a:ext cx="3505200" cy="1937420"/>
           </a:xfrm>
           <a:prstGeom prst="rect">
@@ -4267,7 +4267,7 @@
         </p:nvSpPr>
         <p:spPr>
           <a:xfrm>
-            <a:off x="8107680" y="2548119"/>
+            <a:off x="8107680" y="1993392"/>
             <a:ext cx="3505200" cy="292608"/>
           </a:xfrm>
           <a:prstGeom prst="rect">
@@ -4323,7 +4323,7 @@
         </p:blipFill>
         <p:spPr>
           <a:xfrm>
-            <a:off x="8107680" y="2886447"/>
+            <a:off x="8107680" y="2331720"/>
             <a:ext cx="3505200" cy="1909337"/>
           </a:xfrm>
           <a:prstGeom prst="rect">

</xml_diff>

<commit_message>
Competitor brand search slide: 2x2 grid with exposed vs not-exposed captures
Co-Authored-By: Claude Opus 5.5 <noreply@anthropic.com>
Claude-Session: https://claude.ai/code/session_01LNckV4PF1WFWnv5VJ442kU
</commit_message>
<xml_diff>
--- a/쿠팡_경쟁사브랜드검색_1장.pptx
+++ b/쿠팡_경쟁사브랜드검색_1장.pptx
@@ -3989,7 +3989,7 @@
                 <a:ea typeface="에이투지체 3 Light"/>
                 <a:cs typeface="에이투지체 3 Light"/>
               </a:rPr>
-              <a:t>2026.10.13 쿠팡 PC 검색 화면 기준 (비로그인). 검색 결과는 새로고침, 사용자별로 달라짐 / 키즈픽션·그로스템포·피크하이트 검색에도 두드림 미노출 / 키앤이거 검색에서는 두드림 노출</a:t>
+              <a:t>2026.10.13 쿠팡 PC 검색 화면 기준 (비로그인). 검색 결과는 새로고침, 사용자별로 달라짐 / 키즈픽션·그로스템포·피크하이트 검색에도 두드림 미노출</a:t>
             </a:r>
           </a:p>
         </p:txBody>
@@ -4113,8 +4113,8 @@
         </p:nvSpPr>
         <p:spPr>
           <a:xfrm>
-            <a:off x="548640" y="1993392"/>
-            <a:ext cx="3505200" cy="292608"/>
+            <a:off x="3556647" y="2084832"/>
+            <a:ext cx="2386953" cy="640080"/>
           </a:xfrm>
           <a:prstGeom prst="rect">
             <a:avLst/>
@@ -4137,8 +4137,11 @@
                 <a:ea typeface="에이투지체 8 ExtraBold"/>
                 <a:cs typeface="에이투지체 8 ExtraBold"/>
               </a:rPr>
-              <a:t>"키움정" 검색  </a:t>
-            </a:r>
+              <a:t>"키움정" 검색</a:t>
+            </a:r>
+          </a:p>
+          <a:p>
+            <a:pPr algn="l"/>
             <a:r>
               <a:rPr sz="1250" b="0">
                 <a:solidFill>
@@ -4161,8 +4164,8 @@
         </p:nvSpPr>
         <p:spPr>
           <a:xfrm>
-            <a:off x="4328160" y="1993392"/>
-            <a:ext cx="3505200" cy="292608"/>
+            <a:off x="3580898" y="3867912"/>
+            <a:ext cx="2362702" cy="640080"/>
           </a:xfrm>
           <a:prstGeom prst="rect">
             <a:avLst/>
@@ -4185,8 +4188,11 @@
                 <a:ea typeface="에이투지체 8 ExtraBold"/>
                 <a:cs typeface="에이투지체 8 ExtraBold"/>
               </a:rPr>
-              <a:t>"하우투키" 검색  </a:t>
-            </a:r>
+              <a:t>"하우투키" 검색</a:t>
+            </a:r>
+          </a:p>
+          <a:p>
+            <a:pPr algn="l"/>
             <a:r>
               <a:rPr sz="1250" b="0">
                 <a:solidFill>
@@ -4217,8 +4223,8 @@
         </p:blipFill>
         <p:spPr>
           <a:xfrm>
-            <a:off x="548640" y="2331720"/>
-            <a:ext cx="3505200" cy="1953786"/>
+            <a:off x="548640" y="1993392"/>
+            <a:ext cx="2870847" cy="1600200"/>
           </a:xfrm>
           <a:prstGeom prst="rect">
             <a:avLst/>
@@ -4246,8 +4252,8 @@
         </p:blipFill>
         <p:spPr>
           <a:xfrm>
-            <a:off x="4328160" y="2331720"/>
-            <a:ext cx="3505200" cy="1937420"/>
+            <a:off x="548640" y="3776472"/>
+            <a:ext cx="2895098" cy="1600200"/>
           </a:xfrm>
           <a:prstGeom prst="rect">
             <a:avLst/>
@@ -4267,8 +4273,8 @@
         </p:nvSpPr>
         <p:spPr>
           <a:xfrm>
-            <a:off x="8107680" y="1993392"/>
-            <a:ext cx="3505200" cy="292608"/>
+            <a:off x="9292761" y="2084832"/>
+            <a:ext cx="2320119" cy="640080"/>
           </a:xfrm>
           <a:prstGeom prst="rect">
             <a:avLst/>
@@ -4291,8 +4297,11 @@
                 <a:ea typeface="에이투지체 8 ExtraBold"/>
                 <a:cs typeface="에이투지체 8 ExtraBold"/>
               </a:rPr>
-              <a:t>"종근당아이커키성장" 검색  </a:t>
-            </a:r>
+              <a:t>"종근당아이커키성장" 검색</a:t>
+            </a:r>
+          </a:p>
+          <a:p>
+            <a:pPr algn="l"/>
             <a:r>
               <a:rPr sz="1250" b="0">
                 <a:solidFill>
@@ -4323,8 +4332,8 @@
         </p:blipFill>
         <p:spPr>
           <a:xfrm>
-            <a:off x="8107680" y="2331720"/>
-            <a:ext cx="3505200" cy="1909337"/>
+            <a:off x="6217920" y="1993392"/>
+            <a:ext cx="2937681" cy="1600200"/>
           </a:xfrm>
           <a:prstGeom prst="rect">
             <a:avLst/>
@@ -4336,6 +4345,86 @@
           </a:ln>
         </p:spPr>
       </p:pic>
+      <p:pic>
+        <p:nvPicPr>
+          <p:cNvPr id="21" name="Picture 32" descr="howtoki.png"/>
+          <p:cNvPicPr>
+            <a:picLocks noChangeAspect="1"/>
+          </p:cNvPicPr>
+          <p:nvPr/>
+        </p:nvPicPr>
+        <p:blipFill>
+          <a:blip r:embed="rId10"/>
+          <a:stretch>
+            <a:fillRect/>
+          </a:stretch>
+        </p:blipFill>
+        <p:spPr>
+          <a:xfrm>
+            <a:off x="6217920" y="3776472"/>
+            <a:ext cx="3477450" cy="1600200"/>
+          </a:xfrm>
+          <a:prstGeom prst="rect">
+            <a:avLst/>
+          </a:prstGeom>
+          <a:ln w="9525">
+            <a:solidFill>
+              <a:srgbClr val="DDDDDD"/>
+            </a:solidFill>
+          </a:ln>
+        </p:spPr>
+      </p:pic>
+      <p:sp>
+        <p:nvSpPr>
+          <p:cNvPr id="20" name="TextBox 33"/>
+          <p:cNvSpPr txBox="1"/>
+          <p:nvPr/>
+        </p:nvSpPr>
+        <p:spPr>
+          <a:xfrm>
+            <a:off x="9832530" y="3867912"/>
+            <a:ext cx="1780350" cy="640080"/>
+          </a:xfrm>
+          <a:prstGeom prst="rect">
+            <a:avLst/>
+          </a:prstGeom>
+          <a:noFill/>
+        </p:spPr>
+        <p:txBody>
+          <a:bodyPr wrap="square" lIns="0" tIns="0" rIns="0" bIns="0" anchor="t">
+            <a:spAutoFit/>
+          </a:bodyPr>
+          <a:lstStyle/>
+          <a:p>
+            <a:pPr algn="l"/>
+            <a:r>
+              <a:rPr sz="1250" b="0">
+                <a:solidFill>
+                  <a:srgbClr val="004F9F"/>
+                </a:solidFill>
+                <a:latin typeface="에이투지체 8 ExtraBold"/>
+                <a:ea typeface="에이투지체 8 ExtraBold"/>
+                <a:cs typeface="에이투지체 8 ExtraBold"/>
+              </a:rPr>
+              <a:t>"키앤이거" 검색</a:t>
+            </a:r>
+          </a:p>
+          <a:p>
+            <a:pPr algn="l"/>
+            <a:r>
+              <a:rPr sz="1250" b="0">
+                <a:solidFill>
+                  <a:srgbClr val="222222"/>
+                </a:solidFill>
+                <a:latin typeface="에이투지체 6 SemiBold"/>
+                <a:ea typeface="에이투지체 6 SemiBold"/>
+                <a:cs typeface="에이투지체 6 SemiBold"/>
+              </a:rPr>
+              <a:t>두드림 광고 노출</a:t>
+            </a:r>
+          </a:p>
+        </p:txBody>
+      </p:sp>
     </p:spTree>
   </p:cSld>
   <p:clrMapOvr>

</xml_diff>